<commit_message>
Add team roll numbers and mentor to project deliverables
</commit_message>
<xml_diff>
--- a/deliverables/PoseLab_Research_Presentation.pptx
+++ b/deliverables/PoseLab_Research_Presentation.pptx
@@ -449,7 +449,7 @@
           <a:lstStyle xmlns:a="http://schemas.openxmlformats.org/drawingml/2006/main"/>
           <a:p xmlns:a="http://schemas.openxmlformats.org/drawingml/2006/main">
             <a:r>
-              <a:t>Mini Project II, seventh semester, August to November 2026. Add the actual team members, roll numbers and supervisor before institutional submission. We evaluate an extension around the authors' pretrained graph model. Measured results generated 2026-10-11T23:17:40.737167+05:30.</a:t>
+              <a:t>Mini Project II, seventh semester, August to November 2026. Team roll numbers: 23bcs019, 23bcs007, 23bcs021. Mentor: SUNIL CK. We evaluate an extension around the authors' pretrained graph model. Measured results generated 2026-10-11T23:17:40.737167+05:30.</a:t>
             </a:r>
           </a:p>
           <a:p xmlns:a="http://schemas.openxmlformats.org/drawingml/2006/main">
@@ -3688,6 +3688,7 @@
           </a:lstStyle>
           <a:p xmlns:a="http://schemas.openxmlformats.org/drawingml/2006/main">
             <a:pPr>
+              <a:buNone/>
               <a:defRPr sz="1275" b="0">
                 <a:solidFill>
                   <a:srgbClr val="BACCC5"/>
@@ -3756,6 +3757,7 @@
           </a:lstStyle>
           <a:p xmlns:a="http://schemas.openxmlformats.org/drawingml/2006/main">
             <a:pPr>
+              <a:buNone/>
               <a:defRPr sz="1575" b="0">
                 <a:solidFill>
                   <a:srgbClr val="D6E998"/>
@@ -3824,6 +3826,7 @@
           </a:lstStyle>
           <a:p xmlns:a="http://schemas.openxmlformats.org/drawingml/2006/main">
             <a:pPr>
+              <a:buNone/>
               <a:defRPr sz="1800" b="1">
                 <a:solidFill>
                   <a:srgbClr val="D6E998"/>
@@ -3892,6 +3895,7 @@
           </a:lstStyle>
           <a:p xmlns:a="http://schemas.openxmlformats.org/drawingml/2006/main">
             <a:pPr>
+              <a:buNone/>
               <a:defRPr sz="5700" b="1">
                 <a:solidFill>
                   <a:srgbClr val="FFFFFF"/>
@@ -3960,6 +3964,7 @@
           </a:lstStyle>
           <a:p xmlns:a="http://schemas.openxmlformats.org/drawingml/2006/main">
             <a:pPr>
+              <a:buNone/>
               <a:defRPr sz="3600" b="0">
                 <a:solidFill>
                   <a:srgbClr val="FFFFFF"/>
@@ -3983,6 +3988,7 @@
           </a:p>
           <a:p xmlns:a="http://schemas.openxmlformats.org/drawingml/2006/main">
             <a:pPr>
+              <a:buNone/>
               <a:defRPr sz="3600" b="0">
                 <a:solidFill>
                   <a:srgbClr val="FFFFFF"/>
@@ -4022,8 +4028,8 @@
         </p:nvSpPr>
         <p:spPr>
           <a:xfrm xmlns:a="http://schemas.openxmlformats.org/drawingml/2006/main">
-            <a:off x="685800" y="4657725"/>
-            <a:ext cx="10572750" cy="714375"/>
+            <a:off x="685800" y="4295775"/>
+            <a:ext cx="10572750" cy="381000"/>
           </a:xfrm>
           <a:prstGeom xmlns:a="http://schemas.openxmlformats.org/drawingml/2006/main" prst="rect">
             <a:avLst/>
@@ -4051,6 +4057,7 @@
           </a:lstStyle>
           <a:p xmlns:a="http://schemas.openxmlformats.org/drawingml/2006/main">
             <a:pPr>
+              <a:buNone/>
               <a:defRPr sz="2100" b="0">
                 <a:solidFill>
                   <a:srgbClr val="D9E4DE"/>
@@ -4090,8 +4097,8 @@
         </p:nvSpPr>
         <p:spPr>
           <a:xfrm xmlns:a="http://schemas.openxmlformats.org/drawingml/2006/main">
-            <a:off x="685800" y="5562600"/>
-            <a:ext cx="10287000" cy="619125"/>
+            <a:off x="685800" y="5734050"/>
+            <a:ext cx="10287000" cy="552450"/>
           </a:xfrm>
           <a:prstGeom xmlns:a="http://schemas.openxmlformats.org/drawingml/2006/main" prst="rect">
             <a:avLst/>
@@ -4107,7 +4114,7 @@
           </a:bodyPr>
           <a:lstStyle xmlns:a="http://schemas.openxmlformats.org/drawingml/2006/main">
             <a:defPPr>
-              <a:defRPr sz="1800" b="0">
+              <a:defRPr sz="1725" b="0">
                 <a:solidFill>
                   <a:srgbClr val="D6E998"/>
                 </a:solidFill>
@@ -4119,7 +4126,8 @@
           </a:lstStyle>
           <a:p xmlns:a="http://schemas.openxmlformats.org/drawingml/2006/main">
             <a:pPr>
-              <a:defRPr sz="1800" b="0">
+              <a:buNone/>
+              <a:defRPr sz="1725" b="0">
                 <a:solidFill>
                   <a:srgbClr val="D6E998"/>
                 </a:solidFill>
@@ -4129,7 +4137,7 @@
               </a:defRPr>
             </a:pPr>
             <a:r>
-              <a:rPr sz="1800" b="0">
+              <a:rPr sz="1725" b="0">
                 <a:solidFill>
                   <a:srgbClr val="D6E998"/>
                 </a:solidFill>
@@ -4142,7 +4150,8 @@
           </a:p>
           <a:p xmlns:a="http://schemas.openxmlformats.org/drawingml/2006/main">
             <a:pPr>
-              <a:defRPr sz="1800" b="0">
+              <a:buNone/>
+              <a:defRPr sz="1725" b="0">
                 <a:solidFill>
                   <a:srgbClr val="D6E998"/>
                 </a:solidFill>
@@ -4152,7 +4161,7 @@
               </a:defRPr>
             </a:pPr>
             <a:r>
-              <a:rPr sz="1800" b="0">
+              <a:rPr sz="1725" b="0">
                 <a:solidFill>
                   <a:srgbClr val="D6E998"/>
                 </a:solidFill>
@@ -4161,6 +4170,142 @@
                 <a:cs typeface="Arial"/>
               </a:rPr>
               <a:t>Measured experiment: 11 October 2026</a:t>
+            </a:r>
+          </a:p>
+        </p:txBody>
+      </p:sp>
+      <p:sp>
+        <p:nvSpPr>
+          <p:cNvPr id="9" name="">
+            <a:extLst xmlns:a="http://schemas.openxmlformats.org/drawingml/2006/main">
+              <a:ext uri="{FF2B5EF4-FFF2-40B4-BE49-F238E27FC236}">
+                <a16:creationId xmlns:a16="http://schemas.microsoft.com/office/drawing/2014/main" id="{107F6471-EB8A-481A-AF7D-F2D9AD41CC1B}"/>
+              </a:ext>
+            </a:extLst>
+          </p:cNvPr>
+          <p:cNvSpPr>
+            <a:spLocks xmlns:a="http://schemas.openxmlformats.org/drawingml/2006/main" noGrp="1"/>
+          </p:cNvSpPr>
+          <p:nvPr/>
+        </p:nvSpPr>
+        <p:spPr>
+          <a:xfrm xmlns:a="http://schemas.openxmlformats.org/drawingml/2006/main">
+            <a:off x="685800" y="4819650"/>
+            <a:ext cx="10572750" cy="342900"/>
+          </a:xfrm>
+          <a:prstGeom xmlns:a="http://schemas.openxmlformats.org/drawingml/2006/main" prst="rect">
+            <a:avLst/>
+          </a:prstGeom>
+          <a:noFill xmlns:a="http://schemas.openxmlformats.org/drawingml/2006/main"/>
+          <a:ln xmlns:a="http://schemas.openxmlformats.org/drawingml/2006/main" w="0">
+            <a:noFill/>
+          </a:ln>
+        </p:spPr>
+        <p:txBody>
+          <a:bodyPr xmlns:a="http://schemas.openxmlformats.org/drawingml/2006/main" lIns="0" tIns="0" rIns="0" bIns="0">
+            <a:noAutofit/>
+          </a:bodyPr>
+          <a:lstStyle xmlns:a="http://schemas.openxmlformats.org/drawingml/2006/main">
+            <a:defPPr>
+              <a:defRPr sz="1950">
+                <a:solidFill>
+                  <a:srgbClr val="FFFFFF"/>
+                </a:solidFill>
+                <a:latin typeface="Arial"/>
+                <a:ea typeface="Arial"/>
+                <a:cs typeface="Arial"/>
+              </a:defRPr>
+            </a:defPPr>
+          </a:lstStyle>
+          <a:p xmlns:a="http://schemas.openxmlformats.org/drawingml/2006/main">
+            <a:pPr>
+              <a:defRPr sz="1950">
+                <a:solidFill>
+                  <a:srgbClr val="FFFFFF"/>
+                </a:solidFill>
+                <a:latin typeface="Arial"/>
+                <a:ea typeface="Arial"/>
+                <a:cs typeface="Arial"/>
+              </a:defRPr>
+            </a:pPr>
+            <a:r>
+              <a:rPr sz="1950">
+                <a:solidFill>
+                  <a:srgbClr val="FFFFFF"/>
+                </a:solidFill>
+                <a:latin typeface="Arial"/>
+                <a:ea typeface="Arial"/>
+                <a:cs typeface="Arial"/>
+              </a:rPr>
+              <a:t>Team: 23bcs019, 23bcs007, 23bcs021</a:t>
+            </a:r>
+          </a:p>
+        </p:txBody>
+      </p:sp>
+      <p:sp>
+        <p:nvSpPr>
+          <p:cNvPr id="10" name="">
+            <a:extLst xmlns:a="http://schemas.openxmlformats.org/drawingml/2006/main">
+              <a:ext uri="{FF2B5EF4-FFF2-40B4-BE49-F238E27FC236}">
+                <a16:creationId xmlns:a16="http://schemas.microsoft.com/office/drawing/2014/main" id="{1BD25E4E-3D8C-4444-88EE-435D8703FDEA}"/>
+              </a:ext>
+            </a:extLst>
+          </p:cNvPr>
+          <p:cNvSpPr>
+            <a:spLocks xmlns:a="http://schemas.openxmlformats.org/drawingml/2006/main" noGrp="1"/>
+          </p:cNvSpPr>
+          <p:nvPr/>
+        </p:nvSpPr>
+        <p:spPr>
+          <a:xfrm xmlns:a="http://schemas.openxmlformats.org/drawingml/2006/main">
+            <a:off x="685800" y="5219700"/>
+            <a:ext cx="10572750" cy="342900"/>
+          </a:xfrm>
+          <a:prstGeom xmlns:a="http://schemas.openxmlformats.org/drawingml/2006/main" prst="rect">
+            <a:avLst/>
+          </a:prstGeom>
+          <a:noFill xmlns:a="http://schemas.openxmlformats.org/drawingml/2006/main"/>
+          <a:ln xmlns:a="http://schemas.openxmlformats.org/drawingml/2006/main" w="0">
+            <a:noFill/>
+          </a:ln>
+        </p:spPr>
+        <p:txBody>
+          <a:bodyPr xmlns:a="http://schemas.openxmlformats.org/drawingml/2006/main" lIns="0" tIns="0" rIns="0" bIns="0">
+            <a:noAutofit/>
+          </a:bodyPr>
+          <a:lstStyle xmlns:a="http://schemas.openxmlformats.org/drawingml/2006/main">
+            <a:defPPr>
+              <a:defRPr sz="1950">
+                <a:solidFill>
+                  <a:srgbClr val="FFFFFF"/>
+                </a:solidFill>
+                <a:latin typeface="Arial"/>
+                <a:ea typeface="Arial"/>
+                <a:cs typeface="Arial"/>
+              </a:defRPr>
+            </a:defPPr>
+          </a:lstStyle>
+          <a:p xmlns:a="http://schemas.openxmlformats.org/drawingml/2006/main">
+            <a:pPr>
+              <a:defRPr sz="1950">
+                <a:solidFill>
+                  <a:srgbClr val="FFFFFF"/>
+                </a:solidFill>
+                <a:latin typeface="Arial"/>
+                <a:ea typeface="Arial"/>
+                <a:cs typeface="Arial"/>
+              </a:defRPr>
+            </a:pPr>
+            <a:r>
+              <a:rPr sz="1950">
+                <a:solidFill>
+                  <a:srgbClr val="FFFFFF"/>
+                </a:solidFill>
+                <a:latin typeface="Arial"/>
+                <a:ea typeface="Arial"/>
+                <a:cs typeface="Arial"/>
+              </a:rPr>
+              <a:t>Mentor: SUNIL CK</a:t>
             </a:r>
           </a:p>
         </p:txBody>

</xml_diff>